<commit_message>
final push, remove api keys
</commit_message>
<xml_diff>
--- a/pitch.pptx
+++ b/pitch.pptx
@@ -264,7 +264,7 @@
                 <a:latin typeface="Segoe UI"/>
                 <a:ea typeface="Arial"/>
               </a:rPr>
-              <a:t>‹N°›</a:t>
+              <a:t>‹#›</a:t>
             </a:fld>
             <a:endParaRPr lang="en-GB" sz="1000" b="0" u="none" strike="noStrike">
               <a:solidFill>
@@ -805,7 +805,7 @@
                 <a:latin typeface="Segoe UI"/>
                 <a:ea typeface="Arial"/>
               </a:rPr>
-              <a:t>‹N°›</a:t>
+              <a:t>‹#›</a:t>
             </a:fld>
             <a:endParaRPr lang="en-GB" sz="1000" b="0" u="none" strike="noStrike">
               <a:solidFill>
@@ -1768,7 +1768,7 @@
                 <a:latin typeface="Segoe UI"/>
                 <a:ea typeface="Arial"/>
               </a:rPr>
-              <a:t>‹N°›</a:t>
+              <a:t>‹#›</a:t>
             </a:fld>
             <a:endParaRPr lang="en-GB" sz="1000" b="0" u="none" strike="noStrike">
               <a:solidFill>
@@ -2013,7 +2013,7 @@
                 <a:latin typeface="Segoe UI"/>
                 <a:ea typeface="Arial"/>
               </a:rPr>
-              <a:t>‹N°›</a:t>
+              <a:t>‹#›</a:t>
             </a:fld>
             <a:endParaRPr lang="en-GB" sz="1000" b="0" u="none" strike="noStrike">
               <a:solidFill>
@@ -2316,7 +2316,7 @@
                 <a:latin typeface="Segoe UI"/>
                 <a:ea typeface="Arial"/>
               </a:rPr>
-              <a:t>‹N°›</a:t>
+              <a:t>‹#›</a:t>
             </a:fld>
             <a:endParaRPr lang="en-GB" sz="1000" b="0" u="none" strike="noStrike">
               <a:solidFill>
@@ -2619,7 +2619,7 @@
                 <a:latin typeface="Segoe UI"/>
                 <a:ea typeface="Arial"/>
               </a:rPr>
-              <a:t>‹N°›</a:t>
+              <a:t>‹#›</a:t>
             </a:fld>
             <a:endParaRPr lang="en-GB" sz="1000" b="0" u="none" strike="noStrike">
               <a:solidFill>
@@ -2898,7 +2898,7 @@
                 <a:latin typeface="Segoe UI"/>
                 <a:ea typeface="Arial"/>
               </a:rPr>
-              <a:t>‹N°›</a:t>
+              <a:t>‹#›</a:t>
             </a:fld>
             <a:endParaRPr lang="en-GB" sz="1000" b="0" u="none" strike="noStrike">
               <a:solidFill>
@@ -3119,7 +3119,7 @@
                 <a:latin typeface="Segoe UI"/>
                 <a:ea typeface="Arial"/>
               </a:rPr>
-              <a:t>‹N°›</a:t>
+              <a:t>‹#›</a:t>
             </a:fld>
             <a:endParaRPr lang="en-GB" sz="1000" b="0" u="none" strike="noStrike">
               <a:solidFill>
@@ -3340,7 +3340,7 @@
                 <a:latin typeface="Segoe UI"/>
                 <a:ea typeface="Arial"/>
               </a:rPr>
-              <a:t>‹N°›</a:t>
+              <a:t>‹#›</a:t>
             </a:fld>
             <a:endParaRPr lang="en-GB" sz="1000" b="0" u="none" strike="noStrike">
               <a:solidFill>
@@ -3774,7 +3774,7 @@
         </p:spPr>
         <p:txBody>
           <a:bodyPr lIns="91440" tIns="45720" rIns="91440" bIns="45720" anchor="t">
-            <a:normAutofit lnSpcReduction="9999"/>
+            <a:normAutofit lnSpcReduction="10000"/>
           </a:bodyPr>
           <a:lstStyle/>
           <a:p>
@@ -3834,29 +3834,6 @@
           </a:ln>
         </p:spPr>
       </p:pic>
-      <p:sp>
-        <p:nvSpPr>
-          <p:cNvPr id="3" name="PlaceHolder 2"/>
-          <p:cNvSpPr>
-            <a:spLocks noGrp="1"/>
-          </p:cNvSpPr>
-          <p:nvPr>
-            <p:ph type="sldNum" idx="2"/>
-          </p:nvPr>
-        </p:nvSpPr>
-        <p:spPr/>
-        <p:txBody>
-          <a:bodyPr/>
-          <a:lstStyle/>
-          <a:p>
-            <a:fld id="{545679E5-54B7-483B-8378-6A10DE525E2E}" type="slidenum">
-              <a:rPr/>
-              <a:t>1</a:t>
-            </a:fld>
-            <a:endParaRPr/>
-          </a:p>
-        </p:txBody>
-      </p:sp>
     </p:spTree>
   </p:cSld>
   <p:clrMapOvr>
@@ -4061,29 +4038,6 @@
               <a:uFillTx/>
               <a:latin typeface="Arial"/>
             </a:endParaRPr>
-          </a:p>
-        </p:txBody>
-      </p:sp>
-      <p:sp>
-        <p:nvSpPr>
-          <p:cNvPr id="2" name="PlaceHolder 1"/>
-          <p:cNvSpPr>
-            <a:spLocks noGrp="1"/>
-          </p:cNvSpPr>
-          <p:nvPr>
-            <p:ph type="sldNum" idx="1"/>
-          </p:nvPr>
-        </p:nvSpPr>
-        <p:spPr/>
-        <p:txBody>
-          <a:bodyPr/>
-          <a:lstStyle/>
-          <a:p>
-            <a:fld id="{6D960C9D-F41A-4336-A424-36DF766A677D}" type="slidenum">
-              <a:rPr/>
-              <a:t>2</a:t>
-            </a:fld>
-            <a:endParaRPr/>
           </a:p>
         </p:txBody>
       </p:sp>
@@ -5034,7 +4988,7 @@
               </a:lnSpc>
             </a:pPr>
             <a:r>
-              <a:rPr lang="en-GB" sz="2800" b="1" u="none" strike="noStrike">
+              <a:rPr lang="en-GB" sz="2800" b="1" u="none" strike="noStrike" dirty="0">
                 <a:solidFill>
                   <a:srgbClr val="000000"/>
                 </a:solidFill>
@@ -5045,7 +4999,7 @@
               </a:rPr>
               <a:t>Key takeaways</a:t>
             </a:r>
-            <a:endParaRPr lang="en-GB" sz="2800" b="0" u="none" strike="noStrike">
+            <a:endParaRPr lang="en-GB" sz="2800" b="0" u="none" strike="noStrike" dirty="0">
               <a:solidFill>
                 <a:srgbClr val="000000"/>
               </a:solidFill>
@@ -5228,87 +5182,15 @@
           </a:p>
         </p:txBody>
       </p:sp>
-      <p:sp>
-        <p:nvSpPr>
-          <p:cNvPr id="90" name="PlaceHolder 2"/>
-          <p:cNvSpPr>
-            <a:spLocks noGrp="1"/>
-          </p:cNvSpPr>
-          <p:nvPr>
-            <p:ph type="sldNum" idx="10"/>
-          </p:nvPr>
-        </p:nvSpPr>
-        <p:spPr>
-          <a:xfrm>
-            <a:off x="4360320" y="4942080"/>
-            <a:ext cx="423000" cy="201240"/>
-          </a:xfrm>
-          <a:prstGeom prst="rect">
-            <a:avLst/>
-          </a:prstGeom>
-          <a:noFill/>
-          <a:ln w="0">
-            <a:noFill/>
-          </a:ln>
-        </p:spPr>
-        <p:txBody>
-          <a:bodyPr lIns="91440" tIns="45720" rIns="91440" bIns="45720" anchor="ctr">
-            <a:noAutofit/>
-          </a:bodyPr>
-          <a:lstStyle>
-            <a:lvl1pPr indent="0" algn="ctr">
-              <a:lnSpc>
-                <a:spcPct val="100000"/>
-              </a:lnSpc>
-              <a:buNone/>
-              <a:defRPr lang="en-GB" sz="1000" b="0" u="none" strike="noStrike">
-                <a:solidFill>
-                  <a:schemeClr val="lt1">
-                    <a:lumMod val="50000"/>
-                  </a:schemeClr>
-                </a:solidFill>
-                <a:effectLst/>
-                <a:uFillTx/>
-                <a:latin typeface="Segoe UI"/>
-                <a:ea typeface="Arial"/>
-              </a:defRPr>
-            </a:lvl1pPr>
-          </a:lstStyle>
-          <a:p>
-            <a:pPr indent="0" algn="ctr">
-              <a:lnSpc>
-                <a:spcPct val="100000"/>
-              </a:lnSpc>
-              <a:buNone/>
-            </a:pPr>
-            <a:fld id="{40DA5761-157A-48F3-9E4F-4CC655FE5145}" type="slidenum">
-              <a:rPr lang="en-GB" sz="1000" b="0" u="none" strike="noStrike">
-                <a:solidFill>
-                  <a:schemeClr val="lt1">
-                    <a:lumMod val="50000"/>
-                  </a:schemeClr>
-                </a:solidFill>
-                <a:effectLst/>
-                <a:uFillTx/>
-                <a:latin typeface="Segoe UI"/>
-                <a:ea typeface="Arial"/>
-              </a:rPr>
-              <a:t>5</a:t>
-            </a:fld>
-            <a:endParaRPr lang="en-GB" sz="1000" b="0" u="none" strike="noStrike">
-              <a:solidFill>
-                <a:srgbClr val="000000"/>
-              </a:solidFill>
-              <a:effectLst/>
-              <a:uFillTx/>
-              <a:latin typeface="Noto Serif"/>
-            </a:endParaRPr>
-          </a:p>
-        </p:txBody>
-      </p:sp>
       <p:pic>
         <p:nvPicPr>
-          <p:cNvPr id="91" name="Image 90"/>
+          <p:cNvPr id="2" name="Picture 6">
+            <a:extLst>
+              <a:ext uri="{FF2B5EF4-FFF2-40B4-BE49-F238E27FC236}">
+                <a16:creationId xmlns:a16="http://schemas.microsoft.com/office/drawing/2014/main" id="{B28239CC-8C6D-E4A7-CB54-B5BC986D2E34}"/>
+              </a:ext>
+            </a:extLst>
+          </p:cNvPr>
           <p:cNvPicPr/>
           <p:nvPr/>
         </p:nvPicPr>
@@ -5318,15 +5200,17 @@
         </p:blipFill>
         <p:spPr>
           <a:xfrm>
-            <a:off x="6167880" y="275760"/>
-            <a:ext cx="2400120" cy="4584240"/>
+            <a:off x="6400868" y="484333"/>
+            <a:ext cx="1975680" cy="3910680"/>
           </a:xfrm>
           <a:prstGeom prst="rect">
             <a:avLst/>
           </a:prstGeom>
           <a:noFill/>
-          <a:ln w="38160">
-            <a:noFill/>
+          <a:ln w="0">
+            <a:solidFill>
+              <a:srgbClr val="777777"/>
+            </a:solidFill>
           </a:ln>
         </p:spPr>
       </p:pic>

</xml_diff>